<commit_message>
feat(slides): reorder to 7 slides — data slide moves to position 4 (Ian)
Changes:
- Deleted commodity Challenge slide (silent commodity starvation story)
- Moved data-scale slide (formerly slide 7) to position 4, after Methods
- Changed presenter on data slide: Alvin → Ian
- Updated Title slide attribution: Ian sections 1-4, Alvin 5-7
- Updated all slide counters (XX/08 → XX/07) and help-overlay jump-key hint
- Fixed black-edge halo on rendered PNGs: matched body background to deck
  background and removed deck box-shadow (only affected screenshot output;
  on-screen presentation already looked correct)

Final order: Title → Problem → Methods → Data Scale → Results → Live → Conclusions

Co-Authored-By: Claude Opus 4.7 (1M context) <noreply@anthropic.com>
</commit_message>
<xml_diff>
--- a/slides_deck.pptx
+++ b/slides_deck.pptx
@@ -12,7 +12,6 @@
     <p:sldId id="260" r:id="rId11"/>
     <p:sldId id="261" r:id="rId12"/>
     <p:sldId id="262" r:id="rId13"/>
-    <p:sldId id="263" r:id="rId14"/>
   </p:sldIdLst>
   <p:sldSz cx="12191695" cy="6858000" type="screen4x3"/>
   <p:notesSz cx="6858000" cy="9144000"/>
@@ -3379,48 +3378,6 @@
 </p:sld>
 </file>
 
-<file path=ppt/slides/slide8.xml><?xml version="1.0" encoding="utf-8"?>
-<p:sld xmlns:a="http://schemas.openxmlformats.org/drawingml/2006/main" xmlns:p="http://schemas.openxmlformats.org/presentationml/2006/main" xmlns:r="http://schemas.openxmlformats.org/officeDocument/2006/relationships">
-  <p:cSld>
-    <p:spTree>
-      <p:nvGrpSpPr>
-        <p:cNvPr id="1" name=""/>
-        <p:cNvGrpSpPr/>
-        <p:nvPr/>
-      </p:nvGrpSpPr>
-      <p:grpSpPr/>
-      <p:pic>
-        <p:nvPicPr>
-          <p:cNvPr id="2" name="Picture 1" descr="slide-8.png"/>
-          <p:cNvPicPr>
-            <a:picLocks noChangeAspect="1"/>
-          </p:cNvPicPr>
-          <p:nvPr/>
-        </p:nvPicPr>
-        <p:blipFill>
-          <a:blip r:embed="rId2"/>
-          <a:stretch>
-            <a:fillRect/>
-          </a:stretch>
-        </p:blipFill>
-        <p:spPr>
-          <a:xfrm>
-            <a:off x="0" y="0"/>
-            <a:ext cx="12191695" cy="6858000"/>
-          </a:xfrm>
-          <a:prstGeom prst="rect">
-            <a:avLst/>
-          </a:prstGeom>
-        </p:spPr>
-      </p:pic>
-    </p:spTree>
-  </p:cSld>
-  <p:clrMapOvr>
-    <a:masterClrMapping/>
-  </p:clrMapOvr>
-</p:sld>
-</file>
-
 <file path=ppt/theme/theme1.xml><?xml version="1.0" encoding="utf-8"?>
 <a:theme xmlns:a="http://schemas.openxmlformats.org/drawingml/2006/main" name="Office Theme">
   <a:themeElements>

</xml_diff>